<commit_message>
Deck: trim slide 6 demo script to fit layout
</commit_message>
<xml_diff>
--- a/larpers_KBC2026.pptx
+++ b/larpers_KBC2026.pptx
@@ -5042,7 +5042,7 @@
                 </a:solidFill>
                 <a:latin typeface="Calibri"/>
               </a:rPr>
-              <a:t>2. System parses → simulates: 2 sessions moved (Opening Keynote, Panel: Fundraising 101), P0 capacity risk (120 &lt; 200 attendees), 3 tasks rewritten, 3 volunteers flagged, comms draft created → applies to Notion live.</a:t>
+              <a:t>2. System parses → simulates: 2 sessions moved, P0 capacity risk (120 &lt; 200), 3 tasks rewritten, 3 volunteers flagged, comms draft created → applies to Notion live.</a:t>
             </a:r>
           </a:p>
           <a:p>
@@ -5090,7 +5090,7 @@
                 </a:solidFill>
                 <a:latin typeface="Calibri"/>
               </a:rPr>
-              <a:t>5. Insight: P0 overflow risk surfaced + follow-up tasks auto-created; post-event, one click compiles the knowledge base.</a:t>
+              <a:t>5. Insight: P0 overflow risk + auto-created tasks; post-event, one click compiles the knowledge base.</a:t>
             </a:r>
           </a:p>
           <a:p>

</xml_diff>

<commit_message>
Slide 6: insert dashboard screenshot
</commit_message>
<xml_diff>
--- a/larpers_KBC2026.pptx
+++ b/larpers_KBC2026.pptx
@@ -4866,43 +4866,6 @@
       </p:sp>
       <p:sp>
         <p:nvSpPr>
-          <p:cNvPr id="9" name="Text 7"/>
-          <p:cNvSpPr txBox="1"/>
-          <p:nvPr/>
-        </p:nvSpPr>
-        <p:spPr>
-          <a:xfrm>
-            <a:off x="457200" y="1417320"/>
-            <a:ext cx="4206240" cy="3108960"/>
-          </a:xfrm>
-          <a:prstGeom prst="rect">
-            <a:avLst/>
-          </a:prstGeom>
-          <a:noFill/>
-          <a:ln/>
-        </p:spPr>
-        <p:txBody>
-          <a:bodyPr wrap="square" lIns="0" tIns="0" rIns="0" bIns="0" rtlCol="0" anchor="ctr"/>
-          <a:lstStyle/>
-          <a:p>
-            <a:pPr algn="ctr" indent="0" marL="0">
-              <a:buNone/>
-            </a:pPr>
-            <a:r>
-              <a:rPr sz="1300" i="1">
-                <a:solidFill>
-                  <a:srgbClr val="2E2A52"/>
-                </a:solidFill>
-                <a:latin typeface="Calibri"/>
-              </a:rPr>
-              <a:t>[Screenshot: Sanchalan dashboard + blast-radius simulation — added after deploy]</a:t>
-            </a:r>
-            <a:endParaRPr lang="en-US" sz="1300" dirty="0"/>
-          </a:p>
-        </p:txBody>
-      </p:sp>
-      <p:sp>
-        <p:nvSpPr>
           <p:cNvPr id="10" name="Shape 8"/>
           <p:cNvSpPr/>
           <p:nvPr/>
@@ -5111,6 +5074,30 @@
           </a:p>
         </p:txBody>
       </p:sp>
+      <p:pic>
+        <p:nvPicPr>
+          <p:cNvPr id="14" name="Picture 13" descr="sanchalan_dash.png"/>
+          <p:cNvPicPr>
+            <a:picLocks noChangeAspect="1"/>
+          </p:cNvPicPr>
+          <p:nvPr/>
+        </p:nvPicPr>
+        <p:blipFill>
+          <a:blip r:embed="rId3"/>
+          <a:stretch>
+            <a:fillRect/>
+          </a:stretch>
+        </p:blipFill>
+        <p:spPr>
+          <a:xfrm>
+            <a:off x="457200" y="1450291"/>
+            <a:ext cx="4206240" cy="3043017"/>
+          </a:xfrm>
+          <a:prstGeom prst="rect">
+            <a:avLst/>
+          </a:prstGeom>
+        </p:spPr>
+      </p:pic>
     </p:spTree>
   </p:cSld>
   <p:clrMapOvr>

</xml_diff>

<commit_message>
Add blast-radius screenshot to slide 6, finalize deck
</commit_message>
<xml_diff>
--- a/larpers_KBC2026.pptx
+++ b/larpers_KBC2026.pptx
@@ -4961,8 +4961,8 @@
         </p:nvSpPr>
         <p:spPr>
           <a:xfrm>
-            <a:off x="5029200" y="1874520"/>
-            <a:ext cx="3520440" cy="2560320"/>
+            <a:off x="4983480" y="1783080"/>
+            <a:ext cx="3566160" cy="457200"/>
           </a:xfrm>
           <a:prstGeom prst="rect">
             <a:avLst/>
@@ -4974,102 +4974,9 @@
           <a:bodyPr wrap="square" lIns="0" tIns="0" rIns="0" bIns="0" rtlCol="0" anchor="t"/>
           <a:lstStyle/>
           <a:p>
-            <a:pPr marL="342900" indent="-342900">
-              <a:spcAft>
-                <a:spcPts val="400"/>
-              </a:spcAft>
-              <a:buSzPct val="100000"/>
-              <a:buChar char="•"/>
-            </a:pPr>
-            <a:r>
-              <a:rPr sz="1200">
-                <a:solidFill>
-                  <a:srgbClr val="2E2A52"/>
-                </a:solidFill>
-                <a:latin typeface="Calibri"/>
-              </a:rPr>
-              <a:t>1. Input arrives: “Main Audi is under maintenance — move everything to Seminar Hall B.”</a:t>
-            </a:r>
-            <a:endParaRPr lang="en-US" sz="1200" dirty="0"/>
-          </a:p>
-          <a:p>
-            <a:pPr>
-              <a:spcAft>
-                <a:spcPts val="400"/>
-              </a:spcAft>
-            </a:pPr>
-            <a:r>
-              <a:rPr sz="1200">
-                <a:solidFill>
-                  <a:srgbClr val="2E2A52"/>
-                </a:solidFill>
-                <a:latin typeface="Calibri"/>
-              </a:rPr>
-              <a:t>2. System parses → simulates: 2 sessions moved, P0 capacity risk (120 &lt; 200), 3 tasks rewritten, 3 volunteers flagged, comms draft created → applies to Notion live.</a:t>
-            </a:r>
-          </a:p>
-          <a:p>
-            <a:pPr>
-              <a:spcAft>
-                <a:spcPts val="400"/>
-              </a:spcAft>
-            </a:pPr>
-            <a:r>
-              <a:rPr sz="1200">
-                <a:solidFill>
-                  <a:srgbClr val="2E2A52"/>
-                </a:solidFill>
-                <a:latin typeface="Calibri"/>
-              </a:rPr>
-              <a:t>3. Role A (Ops lead) reviews the Impact Report in Notion and approves.</a:t>
-            </a:r>
-          </a:p>
-          <a:p>
-            <a:pPr>
-              <a:spcAft>
-                <a:spcPts val="400"/>
-              </a:spcAft>
-            </a:pPr>
-            <a:r>
-              <a:rPr sz="1200">
-                <a:solidFill>
-                  <a:srgbClr val="2E2A52"/>
-                </a:solidFill>
-                <a:latin typeface="Calibri"/>
-              </a:rPr>
-              <a:t>4. Role B (Volunteer lead) sees the updated shift plan; asks “Which volunteers are affected?” — answered with citations.</a:t>
-            </a:r>
-          </a:p>
-          <a:p>
-            <a:pPr>
-              <a:spcAft>
-                <a:spcPts val="400"/>
-              </a:spcAft>
-            </a:pPr>
-            <a:r>
-              <a:rPr sz="1200">
-                <a:solidFill>
-                  <a:srgbClr val="2E2A52"/>
-                </a:solidFill>
-                <a:latin typeface="Calibri"/>
-              </a:rPr>
-              <a:t>5. Insight: P0 overflow risk + auto-created tasks; post-event, one click compiles the knowledge base.</a:t>
-            </a:r>
-          </a:p>
-          <a:p>
-            <a:pPr>
-              <a:spcAft>
-                <a:spcPts val="400"/>
-              </a:spcAft>
-            </a:pPr>
-            <a:r>
-              <a:rPr sz="1200">
-                <a:solidFill>
-                  <a:srgbClr val="2E2A52"/>
-                </a:solidFill>
-                <a:latin typeface="Calibri"/>
-              </a:rPr>
-              <a:t>Demo dataset: synthetic BBSR Founders Meetup #1 — 29 records in a real Notion workspace.</a:t>
+            <a:r>
+              <a:rPr sz="900"/>
+              <a:t>Parse → Simulate → Apply: 2 sessions moved, P0 capacity risk flagged, 3 tasks rewritten, 3 volunteers notified, comms draft created — all written to Notion live.</a:t>
             </a:r>
           </a:p>
         </p:txBody>
@@ -5092,6 +4999,30 @@
           <a:xfrm>
             <a:off x="457200" y="1450291"/>
             <a:ext cx="4206240" cy="3043017"/>
+          </a:xfrm>
+          <a:prstGeom prst="rect">
+            <a:avLst/>
+          </a:prstGeom>
+        </p:spPr>
+      </p:pic>
+      <p:pic>
+        <p:nvPicPr>
+          <p:cNvPr id="15" name="Picture 14" descr="223c8544f278724020de634cb516baefa5ef46057ee525c7bf7d03d60c5bef80.png"/>
+          <p:cNvPicPr>
+            <a:picLocks noChangeAspect="1"/>
+          </p:cNvPicPr>
+          <p:nvPr/>
+        </p:nvPicPr>
+        <p:blipFill>
+          <a:blip r:embed="rId4"/>
+          <a:stretch>
+            <a:fillRect/>
+          </a:stretch>
+        </p:blipFill>
+        <p:spPr>
+          <a:xfrm>
+            <a:off x="4937760" y="2286000"/>
+            <a:ext cx="3657600" cy="2743200"/>
           </a:xfrm>
           <a:prstGeom prst="rect">
             <a:avLst/>

</xml_diff>